<commit_message>
Deck: add the golden eval suite result to the Testing slide
Testing slide restructured from 2 columns to 3: Offline (pytest, 92
tests, plumbing only) | Live Acceptance Run | Golden Eval Suite - Live
Result (14/14, broken down by easy/medium/hard/adversarial), mirroring
ClaimsQL's Golden Suite panel. Also fixes a stale count (91 -> 92 tests).
Applied to both the published HTML deck (republished, same URL) and this
PPTX. Verified 0 off-bounds shapes across all 20 slides after the layout
change.

Co-Authored-By: Claude Sonnet 5 <noreply@anthropic.com>
</commit_message>
<xml_diff>
--- a/docs/Trip Planner Deep Dive.pptx
+++ b/docs/Trip Planner Deep Dive.pptx
@@ -6444,137 +6444,21 @@
                 </a:solidFill>
                 <a:latin typeface="Archivo"/>
               </a:rPr>
-              <a:t>Offline for speed, live for truth.</a:t>
-            </a:r>
-          </a:p>
-        </p:txBody>
-      </p:sp>
-      <p:sp>
-        <p:nvSpPr>
-          <p:cNvPr id="5" name="TextBox 4"/>
-          <p:cNvSpPr txBox="1"/>
-          <p:nvPr/>
-        </p:nvSpPr>
-        <p:spPr>
-          <a:xfrm>
-            <a:off x="502920" y="1874519"/>
-            <a:ext cx="5394960" cy="3200400"/>
-          </a:xfrm>
-          <a:prstGeom prst="rect">
-            <a:avLst/>
-          </a:prstGeom>
-          <a:noFill/>
-        </p:spPr>
-        <p:txBody>
-          <a:bodyPr wrap="square" lIns="0" rIns="0" tIns="0" bIns="0">
-            <a:spAutoFit/>
-          </a:bodyPr>
-          <a:lstStyle/>
-          <a:p>
-            <a:pPr>
-              <a:lnSpc>
-                <a:spcPct val="118000"/>
-              </a:lnSpc>
-              <a:spcAft>
-                <a:spcPts val="800"/>
-              </a:spcAft>
-            </a:pPr>
-            <a:r>
-              <a:rPr sz="1300" b="1">
-                <a:solidFill>
-                  <a:srgbClr val="0E7C8C"/>
-                </a:solidFill>
-                <a:latin typeface="Archivo"/>
-              </a:rPr>
-              <a:t>▸  </a:t>
-            </a:r>
-            <a:r>
-              <a:rPr sz="1300" b="1">
-                <a:solidFill>
-                  <a:srgbClr val="1E2224"/>
-                </a:solidFill>
-                <a:latin typeface="Archivo"/>
-              </a:rPr>
-              <a:t>92 tests</a:t>
-            </a:r>
-            <a:r>
-              <a:rPr sz="1300" b="0">
-                <a:solidFill>
-                  <a:srgbClr val="52585D"/>
-                </a:solidFill>
-                <a:latin typeface="Archivo"/>
-              </a:rPr>
-              <a:t> pass fully offline — fixtures/fakes for Qdrant, embeddings, and every LLM call, no live keys required</a:t>
-            </a:r>
-          </a:p>
-          <a:p>
-            <a:pPr>
-              <a:lnSpc>
-                <a:spcPct val="118000"/>
-              </a:lnSpc>
-              <a:spcAft>
-                <a:spcPts val="800"/>
-              </a:spcAft>
-            </a:pPr>
-            <a:r>
-              <a:rPr sz="1300" b="1">
-                <a:solidFill>
-                  <a:srgbClr val="0E7C8C"/>
-                </a:solidFill>
-                <a:latin typeface="Archivo"/>
-              </a:rPr>
-              <a:t>▸  </a:t>
-            </a:r>
-            <a:r>
-              <a:rPr sz="1300">
-                <a:solidFill>
-                  <a:srgbClr val="52585D"/>
-                </a:solidFill>
-                <a:latin typeface="Archivo"/>
-              </a:rPr>
-              <a:t>One test exercises a real end-to-end run against live providers, skipped only if OPENAI_API_KEY/DUFFEL_ACCESS_TOKEN are absent</a:t>
-            </a:r>
-          </a:p>
-          <a:p>
-            <a:pPr>
-              <a:lnSpc>
-                <a:spcPct val="118000"/>
-              </a:lnSpc>
-              <a:spcAft>
-                <a:spcPts val="800"/>
-              </a:spcAft>
-            </a:pPr>
-            <a:r>
-              <a:rPr sz="1300" b="1">
-                <a:solidFill>
-                  <a:srgbClr val="0E7C8C"/>
-                </a:solidFill>
-                <a:latin typeface="Archivo"/>
-              </a:rPr>
-              <a:t>▸  </a:t>
-            </a:r>
-            <a:r>
-              <a:rPr sz="1300">
-                <a:solidFill>
-                  <a:srgbClr val="52585D"/>
-                </a:solidFill>
-                <a:latin typeface="Archivo"/>
-              </a:rPr>
-              <a:t>Every guardrail, cache, ledger, and store module has its own dedicated offline test file</a:t>
-            </a:r>
-          </a:p>
-        </p:txBody>
-      </p:sp>
-      <p:sp>
-        <p:nvSpPr>
-          <p:cNvPr id="6" name="Rounded Rectangle 5"/>
+              <a:t>Offline for plumbing, live for truth.</a:t>
+            </a:r>
+          </a:p>
+        </p:txBody>
+      </p:sp>
+      <p:sp>
+        <p:nvSpPr>
+          <p:cNvPr id="5" name="Rounded Rectangle 4"/>
           <p:cNvSpPr/>
           <p:nvPr/>
         </p:nvSpPr>
         <p:spPr>
           <a:xfrm>
-            <a:off x="6126480" y="1874519"/>
-            <a:ext cx="5440680" cy="3200400"/>
+            <a:off x="502920" y="1828800"/>
+            <a:ext cx="3566160" cy="3291840"/>
           </a:xfrm>
           <a:prstGeom prst="roundRect">
             <a:avLst>
@@ -6615,14 +6499,14 @@
       </p:sp>
       <p:sp>
         <p:nvSpPr>
-          <p:cNvPr id="7" name="TextBox 6"/>
+          <p:cNvPr id="6" name="TextBox 5"/>
           <p:cNvSpPr txBox="1"/>
           <p:nvPr/>
         </p:nvSpPr>
         <p:spPr>
           <a:xfrm>
-            <a:off x="6291072" y="2002535"/>
-            <a:ext cx="5111496" cy="274320"/>
+            <a:off x="667512" y="1956816"/>
+            <a:ext cx="3236976" cy="274320"/>
           </a:xfrm>
           <a:prstGeom prst="rect">
             <a:avLst/>
@@ -6647,21 +6531,21 @@
                 </a:solidFill>
                 <a:latin typeface="Consolas"/>
               </a:rPr>
-              <a:t>LIVE ACCEPTANCE RUN</a:t>
-            </a:r>
-          </a:p>
-        </p:txBody>
-      </p:sp>
-      <p:sp>
-        <p:nvSpPr>
-          <p:cNvPr id="8" name="TextBox 7"/>
+              <a:t>OFFLINE (PYTEST)</a:t>
+            </a:r>
+          </a:p>
+        </p:txBody>
+      </p:sp>
+      <p:sp>
+        <p:nvSpPr>
+          <p:cNvPr id="7" name="TextBox 6"/>
           <p:cNvSpPr txBox="1"/>
           <p:nvPr/>
         </p:nvSpPr>
         <p:spPr>
           <a:xfrm>
-            <a:off x="6309360" y="2331720"/>
-            <a:ext cx="5074920" cy="2651760"/>
+            <a:off x="667512" y="2286000"/>
+            <a:ext cx="3236976" cy="2743200"/>
           </a:xfrm>
           <a:prstGeom prst="rect">
             <a:avLst/>
@@ -6679,11 +6563,11 @@
                 <a:spcPct val="118000"/>
               </a:lnSpc>
               <a:spcAft>
-                <a:spcPts val="600"/>
+                <a:spcPts val="800"/>
               </a:spcAft>
             </a:pPr>
             <a:r>
-              <a:rPr sz="1150" b="1">
+              <a:rPr sz="1050" b="1">
                 <a:solidFill>
                   <a:srgbClr val="0E7C8C"/>
                 </a:solidFill>
@@ -6692,13 +6576,22 @@
               <a:t>▸  </a:t>
             </a:r>
             <a:r>
-              <a:rPr sz="1150">
+              <a:rPr sz="1050" b="1">
+                <a:solidFill>
+                  <a:srgbClr val="1E2224"/>
+                </a:solidFill>
+                <a:latin typeface="Archivo"/>
+              </a:rPr>
+              <a:t>92 tests</a:t>
+            </a:r>
+            <a:r>
+              <a:rPr sz="1050" b="0">
                 <a:solidFill>
                   <a:srgbClr val="52585D"/>
                 </a:solidFill>
                 <a:latin typeface="Archivo"/>
               </a:rPr>
-              <a:t>Happy path — real weather, live fares, grounded auto-approve</a:t>
+              <a:t>, fully offline — fixtures/fakes for Qdrant, embeddings, and every LLM call</a:t>
             </a:r>
           </a:p>
           <a:p>
@@ -6707,11 +6600,11 @@
                 <a:spcPct val="118000"/>
               </a:lnSpc>
               <a:spcAft>
-                <a:spcPts val="600"/>
+                <a:spcPts val="800"/>
               </a:spcAft>
             </a:pPr>
             <a:r>
-              <a:rPr sz="1150" b="1">
+              <a:rPr sz="1050" b="1">
                 <a:solidFill>
                   <a:srgbClr val="0E7C8C"/>
                 </a:solidFill>
@@ -6720,13 +6613,13 @@
               <a:t>▸  </a:t>
             </a:r>
             <a:r>
-              <a:rPr sz="1150">
+              <a:rPr sz="1050">
                 <a:solidFill>
                   <a:srgbClr val="52585D"/>
                 </a:solidFill>
                 <a:latin typeface="Archivo"/>
               </a:rPr>
-              <a:t>Repeated search — Redis route-cache hit, zero new Flight Agent LLM cost</a:t>
+              <a:t>Every guardrail, cache, ledger, and store module has its own dedicated test file</a:t>
             </a:r>
           </a:p>
           <a:p>
@@ -6735,11 +6628,11 @@
                 <a:spcPct val="118000"/>
               </a:lnSpc>
               <a:spcAft>
-                <a:spcPts val="600"/>
+                <a:spcPts val="800"/>
               </a:spcAft>
             </a:pPr>
             <a:r>
-              <a:rPr sz="1150" b="1">
+              <a:rPr sz="1050" b="1">
                 <a:solidFill>
                   <a:srgbClr val="0E7C8C"/>
                 </a:solidFill>
@@ -6748,26 +6641,136 @@
               <a:t>▸  </a:t>
             </a:r>
             <a:r>
-              <a:rPr sz="1150">
+              <a:rPr sz="1050">
                 <a:solidFill>
                   <a:srgbClr val="52585D"/>
                 </a:solidFill>
                 <a:latin typeface="Archivo"/>
               </a:rPr>
-              <a:t>Reflection loop — cabin downgraded until in-policy or exhausted</a:t>
-            </a:r>
-          </a:p>
+              <a:t>Checks plumbing, not answer quality — the LLM call itself is mocked</a:t>
+            </a:r>
+          </a:p>
+        </p:txBody>
+      </p:sp>
+      <p:sp>
+        <p:nvSpPr>
+          <p:cNvPr id="8" name="Rounded Rectangle 7"/>
+          <p:cNvSpPr/>
+          <p:nvPr/>
+        </p:nvSpPr>
+        <p:spPr>
+          <a:xfrm>
+            <a:off x="4251960" y="1828800"/>
+            <a:ext cx="3566160" cy="3291840"/>
+          </a:xfrm>
+          <a:prstGeom prst="roundRect">
+            <a:avLst>
+              <a:gd name="adj" fmla="val 3000"/>
+            </a:avLst>
+          </a:prstGeom>
+          <a:solidFill>
+            <a:srgbClr val="FFFFFF"/>
+          </a:solidFill>
+          <a:ln w="12700">
+            <a:solidFill>
+              <a:srgbClr val="E1DCD0"/>
+            </a:solidFill>
+          </a:ln>
+          <a:effectLst/>
+        </p:spPr>
+        <p:style>
+          <a:lnRef idx="1">
+            <a:schemeClr val="accent1"/>
+          </a:lnRef>
+          <a:fillRef idx="3">
+            <a:schemeClr val="accent1"/>
+          </a:fillRef>
+          <a:effectRef idx="2">
+            <a:schemeClr val="accent1"/>
+          </a:effectRef>
+          <a:fontRef idx="minor">
+            <a:schemeClr val="lt1"/>
+          </a:fontRef>
+        </p:style>
+        <p:txBody>
+          <a:bodyPr rtlCol="0" anchor="ctr"/>
+          <a:lstStyle/>
+          <a:p>
+            <a:pPr algn="ctr"/>
+          </a:p>
+        </p:txBody>
+      </p:sp>
+      <p:sp>
+        <p:nvSpPr>
+          <p:cNvPr id="9" name="TextBox 8"/>
+          <p:cNvSpPr txBox="1"/>
+          <p:nvPr/>
+        </p:nvSpPr>
+        <p:spPr>
+          <a:xfrm>
+            <a:off x="4416552" y="1956816"/>
+            <a:ext cx="3236976" cy="274320"/>
+          </a:xfrm>
+          <a:prstGeom prst="rect">
+            <a:avLst/>
+          </a:prstGeom>
+          <a:noFill/>
+        </p:spPr>
+        <p:txBody>
+          <a:bodyPr wrap="square" anchor="t" lIns="0" rIns="0" tIns="0" bIns="0">
+            <a:spAutoFit/>
+          </a:bodyPr>
+          <a:lstStyle/>
+          <a:p>
+            <a:pPr algn="l">
+              <a:lnSpc>
+                <a:spcPct val="100000"/>
+              </a:lnSpc>
+            </a:pPr>
+            <a:r>
+              <a:rPr sz="1050" b="1" i="0">
+                <a:solidFill>
+                  <a:srgbClr val="0E7C8C"/>
+                </a:solidFill>
+                <a:latin typeface="Consolas"/>
+              </a:rPr>
+              <a:t>LIVE ACCEPTANCE RUN</a:t>
+            </a:r>
+          </a:p>
+        </p:txBody>
+      </p:sp>
+      <p:sp>
+        <p:nvSpPr>
+          <p:cNvPr id="10" name="TextBox 9"/>
+          <p:cNvSpPr txBox="1"/>
+          <p:nvPr/>
+        </p:nvSpPr>
+        <p:spPr>
+          <a:xfrm>
+            <a:off x="4416552" y="2286000"/>
+            <a:ext cx="3236976" cy="2743200"/>
+          </a:xfrm>
+          <a:prstGeom prst="rect">
+            <a:avLst/>
+          </a:prstGeom>
+          <a:noFill/>
+        </p:spPr>
+        <p:txBody>
+          <a:bodyPr wrap="square" lIns="0" rIns="0" tIns="0" bIns="0">
+            <a:spAutoFit/>
+          </a:bodyPr>
+          <a:lstStyle/>
           <a:p>
             <a:pPr>
               <a:lnSpc>
                 <a:spcPct val="118000"/>
               </a:lnSpc>
               <a:spcAft>
-                <a:spcPts val="600"/>
+                <a:spcPts val="800"/>
               </a:spcAft>
             </a:pPr>
             <a:r>
-              <a:rPr sz="1150" b="1">
+              <a:rPr sz="1050" b="1">
                 <a:solidFill>
                   <a:srgbClr val="0E7C8C"/>
                 </a:solidFill>
@@ -6776,13 +6779,13 @@
               <a:t>▸  </a:t>
             </a:r>
             <a:r>
-              <a:rPr sz="1150">
+              <a:rPr sz="1050">
                 <a:solidFill>
                   <a:srgbClr val="52585D"/>
                 </a:solidFill>
                 <a:latin typeface="Archivo"/>
               </a:rPr>
-              <a:t>Two personas, one route — correctly divergent caps and approvers</a:t>
+              <a:t>Happy path — real weather, live fares, grounded auto-approve</a:t>
             </a:r>
           </a:p>
           <a:p>
@@ -6791,11 +6794,11 @@
                 <a:spcPct val="118000"/>
               </a:lnSpc>
               <a:spcAft>
-                <a:spcPts val="600"/>
+                <a:spcPts val="800"/>
               </a:spcAft>
             </a:pPr>
             <a:r>
-              <a:rPr sz="1150" b="1">
+              <a:rPr sz="1050" b="1">
                 <a:solidFill>
                   <a:srgbClr val="0E7C8C"/>
                 </a:solidFill>
@@ -6804,13 +6807,13 @@
               <a:t>▸  </a:t>
             </a:r>
             <a:r>
-              <a:rPr sz="1150">
+              <a:rPr sz="1050">
                 <a:solidFill>
                   <a:srgbClr val="52585D"/>
                 </a:solidFill>
                 <a:latin typeface="Archivo"/>
               </a:rPr>
-              <a:t>Negative control — booking blocked without an approval record</a:t>
+              <a:t>Repeated search — Redis route-cache hit, zero new Flight Agent LLM cost</a:t>
             </a:r>
           </a:p>
           <a:p>
@@ -6819,11 +6822,11 @@
                 <a:spcPct val="118000"/>
               </a:lnSpc>
               <a:spcAft>
-                <a:spcPts val="600"/>
+                <a:spcPts val="800"/>
               </a:spcAft>
             </a:pPr>
             <a:r>
-              <a:rPr sz="1150" b="1">
+              <a:rPr sz="1050" b="1">
                 <a:solidFill>
                   <a:srgbClr val="0E7C8C"/>
                 </a:solidFill>
@@ -6832,20 +6835,465 @@
               <a:t>▸  </a:t>
             </a:r>
             <a:r>
-              <a:rPr sz="1150">
+              <a:rPr sz="1050">
                 <a:solidFill>
                   <a:srgbClr val="52585D"/>
                 </a:solidFill>
                 <a:latin typeface="Archivo"/>
               </a:rPr>
-              <a:t>Semantic cache hit — a paraphrased policy question</a:t>
-            </a:r>
-          </a:p>
-        </p:txBody>
-      </p:sp>
-      <p:sp>
-        <p:nvSpPr>
-          <p:cNvPr id="9" name="TextBox 8"/>
+              <a:t>Reflection loop — cabin downgraded until in-policy or exhausted</a:t>
+            </a:r>
+          </a:p>
+          <a:p>
+            <a:pPr>
+              <a:lnSpc>
+                <a:spcPct val="118000"/>
+              </a:lnSpc>
+              <a:spcAft>
+                <a:spcPts val="800"/>
+              </a:spcAft>
+            </a:pPr>
+            <a:r>
+              <a:rPr sz="1050" b="1">
+                <a:solidFill>
+                  <a:srgbClr val="0E7C8C"/>
+                </a:solidFill>
+                <a:latin typeface="Archivo"/>
+              </a:rPr>
+              <a:t>▸  </a:t>
+            </a:r>
+            <a:r>
+              <a:rPr sz="1050">
+                <a:solidFill>
+                  <a:srgbClr val="52585D"/>
+                </a:solidFill>
+                <a:latin typeface="Archivo"/>
+              </a:rPr>
+              <a:t>Two personas, one route — correctly divergent caps and approvers</a:t>
+            </a:r>
+          </a:p>
+          <a:p>
+            <a:pPr>
+              <a:lnSpc>
+                <a:spcPct val="118000"/>
+              </a:lnSpc>
+              <a:spcAft>
+                <a:spcPts val="800"/>
+              </a:spcAft>
+            </a:pPr>
+            <a:r>
+              <a:rPr sz="1050" b="1">
+                <a:solidFill>
+                  <a:srgbClr val="0E7C8C"/>
+                </a:solidFill>
+                <a:latin typeface="Archivo"/>
+              </a:rPr>
+              <a:t>▸  </a:t>
+            </a:r>
+            <a:r>
+              <a:rPr sz="1050">
+                <a:solidFill>
+                  <a:srgbClr val="52585D"/>
+                </a:solidFill>
+                <a:latin typeface="Archivo"/>
+              </a:rPr>
+              <a:t>Negative control — booking blocked without an approval record</a:t>
+            </a:r>
+          </a:p>
+        </p:txBody>
+      </p:sp>
+      <p:sp>
+        <p:nvSpPr>
+          <p:cNvPr id="11" name="Rounded Rectangle 10"/>
+          <p:cNvSpPr/>
+          <p:nvPr/>
+        </p:nvSpPr>
+        <p:spPr>
+          <a:xfrm>
+            <a:off x="8001000" y="1828800"/>
+            <a:ext cx="3566160" cy="3291840"/>
+          </a:xfrm>
+          <a:prstGeom prst="roundRect">
+            <a:avLst>
+              <a:gd name="adj" fmla="val 3000"/>
+            </a:avLst>
+          </a:prstGeom>
+          <a:solidFill>
+            <a:srgbClr val="FFFFFF"/>
+          </a:solidFill>
+          <a:ln w="12700">
+            <a:solidFill>
+              <a:srgbClr val="E1DCD0"/>
+            </a:solidFill>
+          </a:ln>
+          <a:effectLst/>
+        </p:spPr>
+        <p:style>
+          <a:lnRef idx="1">
+            <a:schemeClr val="accent1"/>
+          </a:lnRef>
+          <a:fillRef idx="3">
+            <a:schemeClr val="accent1"/>
+          </a:fillRef>
+          <a:effectRef idx="2">
+            <a:schemeClr val="accent1"/>
+          </a:effectRef>
+          <a:fontRef idx="minor">
+            <a:schemeClr val="lt1"/>
+          </a:fontRef>
+        </p:style>
+        <p:txBody>
+          <a:bodyPr rtlCol="0" anchor="ctr"/>
+          <a:lstStyle/>
+          <a:p>
+            <a:pPr algn="ctr"/>
+          </a:p>
+        </p:txBody>
+      </p:sp>
+      <p:sp>
+        <p:nvSpPr>
+          <p:cNvPr id="12" name="TextBox 11"/>
+          <p:cNvSpPr txBox="1"/>
+          <p:nvPr/>
+        </p:nvSpPr>
+        <p:spPr>
+          <a:xfrm>
+            <a:off x="8165592" y="1956816"/>
+            <a:ext cx="3236976" cy="274320"/>
+          </a:xfrm>
+          <a:prstGeom prst="rect">
+            <a:avLst/>
+          </a:prstGeom>
+          <a:noFill/>
+        </p:spPr>
+        <p:txBody>
+          <a:bodyPr wrap="square" anchor="t" lIns="0" rIns="0" tIns="0" bIns="0">
+            <a:spAutoFit/>
+          </a:bodyPr>
+          <a:lstStyle/>
+          <a:p>
+            <a:pPr algn="l">
+              <a:lnSpc>
+                <a:spcPct val="100000"/>
+              </a:lnSpc>
+            </a:pPr>
+            <a:r>
+              <a:rPr sz="1050" b="1" i="0">
+                <a:solidFill>
+                  <a:srgbClr val="0E7C8C"/>
+                </a:solidFill>
+                <a:latin typeface="Consolas"/>
+              </a:rPr>
+              <a:t>GOLDEN EVAL SUITE — LIVE RESULT</a:t>
+            </a:r>
+          </a:p>
+        </p:txBody>
+      </p:sp>
+      <p:graphicFrame>
+        <p:nvGraphicFramePr>
+          <p:cNvPr id="13" name="Table 12"/>
+          <p:cNvGraphicFramePr>
+            <a:graphicFrameLocks noGrp="1"/>
+          </p:cNvGraphicFramePr>
+          <p:nvPr/>
+        </p:nvGraphicFramePr>
+        <p:xfrm>
+          <a:off x="8165592" y="2331720"/>
+          <a:ext cx="3383280" cy="2468880"/>
+        </p:xfrm>
+        <a:graphic>
+          <a:graphicData uri="http://schemas.openxmlformats.org/drawingml/2006/table">
+            <a:tbl>
+              <a:tblPr bandRow="1">
+                <a:tableStyleId>{5C22544A-7EE6-4342-B048-85BDC9FD1C3A}</a:tableStyleId>
+              </a:tblPr>
+              <a:tblGrid>
+                <a:gridCol w="2011680"/>
+                <a:gridCol w="1371600"/>
+              </a:tblGrid>
+              <a:tr h="411480">
+                <a:tc>
+                  <a:txBody>
+                    <a:bodyPr/>
+                    <a:lstStyle/>
+                    <a:p>
+                      <a:r>
+                        <a:rPr sz="950" b="1">
+                          <a:solidFill>
+                            <a:srgbClr val="767D84"/>
+                          </a:solidFill>
+                          <a:latin typeface="Consolas"/>
+                        </a:rPr>
+                        <a:t> </a:t>
+                      </a:r>
+                    </a:p>
+                  </a:txBody>
+                  <a:tcPr marT="50800" marB="50800">
+                    <a:solidFill>
+                      <a:srgbClr val="FAF8F4"/>
+                    </a:solidFill>
+                  </a:tcPr>
+                </a:tc>
+                <a:tc>
+                  <a:txBody>
+                    <a:bodyPr/>
+                    <a:lstStyle/>
+                    <a:p>
+                      <a:r>
+                        <a:rPr sz="950" b="1">
+                          <a:solidFill>
+                            <a:srgbClr val="767D84"/>
+                          </a:solidFill>
+                          <a:latin typeface="Consolas"/>
+                        </a:rPr>
+                        <a:t> </a:t>
+                      </a:r>
+                    </a:p>
+                  </a:txBody>
+                  <a:tcPr marT="50800" marB="50800">
+                    <a:solidFill>
+                      <a:srgbClr val="FAF8F4"/>
+                    </a:solidFill>
+                  </a:tcPr>
+                </a:tc>
+              </a:tr>
+              <a:tr h="411480">
+                <a:tc>
+                  <a:txBody>
+                    <a:bodyPr wrap="square"/>
+                    <a:lstStyle/>
+                    <a:p>
+                      <a:r>
+                        <a:rPr sz="1200" b="1">
+                          <a:solidFill>
+                            <a:srgbClr val="1E2224"/>
+                          </a:solidFill>
+                          <a:latin typeface="Archivo"/>
+                        </a:rPr>
+                        <a:t>Easy</a:t>
+                      </a:r>
+                    </a:p>
+                  </a:txBody>
+                  <a:tcPr marT="63500" marB="63500">
+                    <a:solidFill>
+                      <a:srgbClr val="FFFFFF"/>
+                    </a:solidFill>
+                  </a:tcPr>
+                </a:tc>
+                <a:tc>
+                  <a:txBody>
+                    <a:bodyPr wrap="square"/>
+                    <a:lstStyle/>
+                    <a:p>
+                      <a:r>
+                        <a:rPr sz="1200" b="1">
+                          <a:solidFill>
+                            <a:srgbClr val="0E7C8C"/>
+                          </a:solidFill>
+                          <a:latin typeface="Consolas"/>
+                        </a:rPr>
+                        <a:t>3/3</a:t>
+                      </a:r>
+                    </a:p>
+                  </a:txBody>
+                  <a:tcPr marT="63500" marB="63500">
+                    <a:solidFill>
+                      <a:srgbClr val="FFFFFF"/>
+                    </a:solidFill>
+                  </a:tcPr>
+                </a:tc>
+              </a:tr>
+              <a:tr h="411480">
+                <a:tc>
+                  <a:txBody>
+                    <a:bodyPr wrap="square"/>
+                    <a:lstStyle/>
+                    <a:p>
+                      <a:r>
+                        <a:rPr sz="1200" b="1">
+                          <a:solidFill>
+                            <a:srgbClr val="1E2224"/>
+                          </a:solidFill>
+                          <a:latin typeface="Archivo"/>
+                        </a:rPr>
+                        <a:t>Medium</a:t>
+                      </a:r>
+                    </a:p>
+                  </a:txBody>
+                  <a:tcPr marT="63500" marB="63500">
+                    <a:solidFill>
+                      <a:srgbClr val="FFFFFF"/>
+                    </a:solidFill>
+                  </a:tcPr>
+                </a:tc>
+                <a:tc>
+                  <a:txBody>
+                    <a:bodyPr wrap="square"/>
+                    <a:lstStyle/>
+                    <a:p>
+                      <a:r>
+                        <a:rPr sz="1200" b="1">
+                          <a:solidFill>
+                            <a:srgbClr val="0E7C8C"/>
+                          </a:solidFill>
+                          <a:latin typeface="Consolas"/>
+                        </a:rPr>
+                        <a:t>4/4</a:t>
+                      </a:r>
+                    </a:p>
+                  </a:txBody>
+                  <a:tcPr marT="63500" marB="63500">
+                    <a:solidFill>
+                      <a:srgbClr val="FFFFFF"/>
+                    </a:solidFill>
+                  </a:tcPr>
+                </a:tc>
+              </a:tr>
+              <a:tr h="411480">
+                <a:tc>
+                  <a:txBody>
+                    <a:bodyPr wrap="square"/>
+                    <a:lstStyle/>
+                    <a:p>
+                      <a:r>
+                        <a:rPr sz="1200" b="1">
+                          <a:solidFill>
+                            <a:srgbClr val="1E2224"/>
+                          </a:solidFill>
+                          <a:latin typeface="Archivo"/>
+                        </a:rPr>
+                        <a:t>Hard</a:t>
+                      </a:r>
+                    </a:p>
+                  </a:txBody>
+                  <a:tcPr marT="63500" marB="63500">
+                    <a:solidFill>
+                      <a:srgbClr val="FFFFFF"/>
+                    </a:solidFill>
+                  </a:tcPr>
+                </a:tc>
+                <a:tc>
+                  <a:txBody>
+                    <a:bodyPr wrap="square"/>
+                    <a:lstStyle/>
+                    <a:p>
+                      <a:r>
+                        <a:rPr sz="1200" b="1">
+                          <a:solidFill>
+                            <a:srgbClr val="0E7C8C"/>
+                          </a:solidFill>
+                          <a:latin typeface="Consolas"/>
+                        </a:rPr>
+                        <a:t>3/3</a:t>
+                      </a:r>
+                    </a:p>
+                  </a:txBody>
+                  <a:tcPr marT="63500" marB="63500">
+                    <a:solidFill>
+                      <a:srgbClr val="FFFFFF"/>
+                    </a:solidFill>
+                  </a:tcPr>
+                </a:tc>
+              </a:tr>
+              <a:tr h="411480">
+                <a:tc>
+                  <a:txBody>
+                    <a:bodyPr wrap="square"/>
+                    <a:lstStyle/>
+                    <a:p>
+                      <a:r>
+                        <a:rPr sz="1200" b="1">
+                          <a:solidFill>
+                            <a:srgbClr val="1E2224"/>
+                          </a:solidFill>
+                          <a:latin typeface="Archivo"/>
+                        </a:rPr>
+                        <a:t>Adversarial</a:t>
+                      </a:r>
+                    </a:p>
+                  </a:txBody>
+                  <a:tcPr marT="63500" marB="63500">
+                    <a:solidFill>
+                      <a:srgbClr val="FFFFFF"/>
+                    </a:solidFill>
+                  </a:tcPr>
+                </a:tc>
+                <a:tc>
+                  <a:txBody>
+                    <a:bodyPr wrap="square"/>
+                    <a:lstStyle/>
+                    <a:p>
+                      <a:r>
+                        <a:rPr sz="1200" b="1">
+                          <a:solidFill>
+                            <a:srgbClr val="0E7C8C"/>
+                          </a:solidFill>
+                          <a:latin typeface="Consolas"/>
+                        </a:rPr>
+                        <a:t>4/4</a:t>
+                      </a:r>
+                    </a:p>
+                  </a:txBody>
+                  <a:tcPr marT="63500" marB="63500">
+                    <a:solidFill>
+                      <a:srgbClr val="FFFFFF"/>
+                    </a:solidFill>
+                  </a:tcPr>
+                </a:tc>
+              </a:tr>
+              <a:tr h="411480">
+                <a:tc>
+                  <a:txBody>
+                    <a:bodyPr wrap="square"/>
+                    <a:lstStyle/>
+                    <a:p>
+                      <a:r>
+                        <a:rPr sz="1200" b="1">
+                          <a:solidFill>
+                            <a:srgbClr val="1E2224"/>
+                          </a:solidFill>
+                          <a:latin typeface="Archivo"/>
+                        </a:rPr>
+                        <a:t>Total</a:t>
+                      </a:r>
+                    </a:p>
+                  </a:txBody>
+                  <a:tcPr marT="63500" marB="63500">
+                    <a:solidFill>
+                      <a:srgbClr val="FFFFFF"/>
+                    </a:solidFill>
+                  </a:tcPr>
+                </a:tc>
+                <a:tc>
+                  <a:txBody>
+                    <a:bodyPr wrap="square"/>
+                    <a:lstStyle/>
+                    <a:p>
+                      <a:r>
+                        <a:rPr sz="1200" b="1">
+                          <a:solidFill>
+                            <a:srgbClr val="2F8558"/>
+                          </a:solidFill>
+                          <a:latin typeface="Consolas"/>
+                        </a:rPr>
+                        <a:t>14/14</a:t>
+                      </a:r>
+                    </a:p>
+                  </a:txBody>
+                  <a:tcPr marT="63500" marB="63500">
+                    <a:solidFill>
+                      <a:srgbClr val="FFFFFF"/>
+                    </a:solidFill>
+                  </a:tcPr>
+                </a:tc>
+              </a:tr>
+            </a:tbl>
+          </a:graphicData>
+        </a:graphic>
+      </p:graphicFrame>
+      <p:sp>
+        <p:nvSpPr>
+          <p:cNvPr id="14" name="TextBox 13"/>
           <p:cNvSpPr txBox="1"/>
           <p:nvPr/>
         </p:nvSpPr>
@@ -6877,7 +7325,7 @@
                 </a:solidFill>
                 <a:latin typeface="Consolas"/>
               </a:rPr>
-              <a:t>Every scenario above ran against the real Duffel, Qdrant, OpenAI, and Redis instances — not mocked.</a:t>
+              <a:t>Every scenario above ran against the real Duffel, Qdrant, OpenAI, and Redis instances — not mocked. The golden suite (scripts/run_policy_eval.py) is scored by structured result — grounded, cited section, cache hit — against expected values verified directly from the policy corpus and guardrail config.</a:t>
             </a:r>
           </a:p>
         </p:txBody>

</xml_diff>